<commit_message>
Trocar slide-fonte do petr por um com altura de caixa representativa
O slide escolhido antes (exemplo 'ROM') tinha a caixa de corpo 3x menor que a
maioria dos slides do mesmo tipo no arquivo real -- o Aula 01 foi montado a
mao no Google Slides, e cada slide teve sua caixa redimensionada
individualmente pra caber o proprio conteudo, entao um exemplo escolhido "a
olho" corria risco de ser atipico. Levantei a altura da caixa de corpo nos
17 slides do mesmo tipo e troquei pro slide de altura mediana (slide 53,
"Operacoes de Arrastar com CTRL, SHIFT e ALT").

Orcamento de caracteres do petr subiu de 304 pra 900 -- explica a explosao
de slides reportada pelo time (759 pra um material de 125 paginas): a caixa
pequena demais fazia quase todo paragrafo real estourar a capacidade e cair
no fallback de corte por frase, gerando um slide por frase em vez de
agrupar varias frases por slide como deveria.
</commit_message>
<xml_diff>
--- a/pptx_templates/PETR_modelo.pptx
+++ b/pptx_templates/PETR_modelo.pptx
@@ -10,7 +10,7 @@
   <p:sldIdLst>
     <p:sldId id="256" r:id="rId6"/>
     <p:sldId id="257" r:id="rId7"/>
-    <p:sldId id="264" r:id="rId14"/>
+    <p:sldId id="308" r:id="rId58"/>
   </p:sldIdLst>
   <p:sldSz cy="6858000" cx="12192000"/>
   <p:notesSz cx="6858000" cy="9144000"/>
@@ -1060,12 +1060,12 @@
 </p:notes>
 </file>
 
-<file path=ppt/notesSlides/notesSlide9.xml><?xml version="1.0" encoding="utf-8"?>
+<file path=ppt/notesSlides/notesSlide53.xml><?xml version="1.0" encoding="utf-8"?>
 <p:notes xmlns:a="http://schemas.openxmlformats.org/drawingml/2006/main" xmlns:r="http://schemas.openxmlformats.org/officeDocument/2006/relationships" xmlns:mc="http://schemas.openxmlformats.org/markup-compatibility/2006" xmlns:mv="urn:schemas-microsoft-com:mac:vml" xmlns:p="http://schemas.openxmlformats.org/presentationml/2006/main" xmlns:c="http://schemas.openxmlformats.org/drawingml/2006/chart" xmlns:dgm="http://schemas.openxmlformats.org/drawingml/2006/diagram" xmlns:o="urn:schemas-microsoft-com:office:office" xmlns:v="urn:schemas-microsoft-com:vml" xmlns:pvml="urn:schemas-microsoft-com:office:powerpoint" xmlns:com="http://schemas.openxmlformats.org/drawingml/2006/compatibility" xmlns:p14="http://schemas.microsoft.com/office/powerpoint/2010/main" xmlns:p15="http://schemas.microsoft.com/office/powerpoint/2012/main" xmlns:ahyp="http://schemas.microsoft.com/office/drawing/2018/hyperlinkcolor" showMasterPhAnim="0" showMasterSp="0">
   <p:cSld>
     <p:spTree>
       <p:nvGrpSpPr>
-        <p:cNvPr id="130" name="Shape 130"/>
+        <p:cNvPr id="456" name="Shape 456"/>
         <p:cNvGrpSpPr/>
         <p:nvPr/>
       </p:nvGrpSpPr>
@@ -1079,7 +1079,7 @@
       </p:grpSpPr>
       <p:sp>
         <p:nvSpPr>
-          <p:cNvPr id="131" name="Google Shape;131;p8:notes"/>
+          <p:cNvPr id="457" name="Google Shape;457;p49:notes"/>
           <p:cNvSpPr txBox="1"/>
           <p:nvPr>
             <p:ph idx="1" type="body"/>
@@ -1126,7 +1126,7 @@
       </p:sp>
       <p:sp>
         <p:nvSpPr>
-          <p:cNvPr id="132" name="Google Shape;132;p8:notes"/>
+          <p:cNvPr id="458" name="Google Shape;458;p49:notes"/>
           <p:cNvSpPr/>
           <p:nvPr>
             <p:ph idx="2" type="sldImg"/>
@@ -14368,12 +14368,12 @@
 </p:sld>
 </file>
 
-<file path=ppt/slides/slide9.xml><?xml version="1.0" encoding="utf-8"?>
+<file path=ppt/slides/slide53.xml><?xml version="1.0" encoding="utf-8"?>
 <p:sld xmlns:a="http://schemas.openxmlformats.org/drawingml/2006/main" xmlns:r="http://schemas.openxmlformats.org/officeDocument/2006/relationships" xmlns:mc="http://schemas.openxmlformats.org/markup-compatibility/2006" xmlns:mv="urn:schemas-microsoft-com:mac:vml" xmlns:p="http://schemas.openxmlformats.org/presentationml/2006/main" xmlns:c="http://schemas.openxmlformats.org/drawingml/2006/chart" xmlns:dgm="http://schemas.openxmlformats.org/drawingml/2006/diagram" xmlns:o="urn:schemas-microsoft-com:office:office" xmlns:v="urn:schemas-microsoft-com:vml" xmlns:pvml="urn:schemas-microsoft-com:office:powerpoint" xmlns:com="http://schemas.openxmlformats.org/drawingml/2006/compatibility" xmlns:p14="http://schemas.microsoft.com/office/powerpoint/2010/main" xmlns:p15="http://schemas.microsoft.com/office/powerpoint/2012/main" xmlns:ahyp="http://schemas.microsoft.com/office/drawing/2018/hyperlinkcolor">
   <p:cSld>
     <p:spTree>
       <p:nvGrpSpPr>
-        <p:cNvPr id="133" name="Shape 133"/>
+        <p:cNvPr id="459" name="Shape 459"/>
         <p:cNvGrpSpPr/>
         <p:nvPr/>
       </p:nvGrpSpPr>
@@ -14387,14 +14387,104 @@
       </p:grpSpPr>
       <p:sp>
         <p:nvSpPr>
-          <p:cNvPr id="134" name="Google Shape;134;p8"/>
+          <p:cNvPr id="460" name="Google Shape;460;p49"/>
           <p:cNvSpPr txBox="1"/>
           <p:nvPr/>
         </p:nvSpPr>
         <p:spPr>
           <a:xfrm>
-            <a:off x="463296" y="1739900"/>
-            <a:ext cx="10941304" cy="1446509"/>
+            <a:off x="523874" y="830628"/>
+            <a:ext cx="11144249" cy="430847"/>
+          </a:xfrm>
+          <a:prstGeom prst="rect">
+            <a:avLst/>
+          </a:prstGeom>
+          <a:noFill/>
+          <a:ln>
+            <a:noFill/>
+          </a:ln>
+        </p:spPr>
+        <p:txBody>
+          <a:bodyPr anchorCtr="0" anchor="t" bIns="45700" lIns="91425" spcFirstLastPara="1" rIns="91425" wrap="square" tIns="45700">
+            <a:spAutoFit/>
+          </a:bodyPr>
+          <a:lstStyle/>
+          <a:p>
+            <a:pPr indent="0" lvl="0" marL="0" marR="0" rtl="0" algn="l">
+              <a:lnSpc>
+                <a:spcPct val="100000"/>
+              </a:lnSpc>
+              <a:spcBef>
+                <a:spcPts val="0"/>
+              </a:spcBef>
+              <a:spcAft>
+                <a:spcPts val="0"/>
+              </a:spcAft>
+              <a:buClr>
+                <a:srgbClr val="000000"/>
+              </a:buClr>
+              <a:buSzPts val="2200"/>
+              <a:buFont typeface="Arial"/>
+              <a:buNone/>
+            </a:pPr>
+            <a:r>
+              <a:rPr b="1" i="0" lang="pt-BR" sz="2200" u="sng" cap="none" strike="noStrike">
+                <a:solidFill>
+                  <a:srgbClr val="2E75B5"/>
+                </a:solidFill>
+                <a:latin typeface="Verdana"/>
+                <a:ea typeface="Verdana"/>
+                <a:cs typeface="Verdana"/>
+                <a:sym typeface="Verdana"/>
+              </a:rPr>
+              <a:t>Operações de Arrastar com CTRL, SHIFT e ALT (</a:t>
+            </a:r>
+            <a:r>
+              <a:rPr b="1" i="1" lang="pt-BR" sz="2200" u="sng" cap="none" strike="noStrike">
+                <a:solidFill>
+                  <a:srgbClr val="2E75B5"/>
+                </a:solidFill>
+                <a:latin typeface="Verdana"/>
+                <a:ea typeface="Verdana"/>
+                <a:cs typeface="Verdana"/>
+                <a:sym typeface="Verdana"/>
+              </a:rPr>
+              <a:t>Drag And Drop</a:t>
+            </a:r>
+            <a:r>
+              <a:rPr b="1" i="0" lang="pt-BR" sz="2200" u="sng" cap="none" strike="noStrike">
+                <a:solidFill>
+                  <a:srgbClr val="2E75B5"/>
+                </a:solidFill>
+                <a:latin typeface="Verdana"/>
+                <a:ea typeface="Verdana"/>
+                <a:cs typeface="Verdana"/>
+                <a:sym typeface="Verdana"/>
+              </a:rPr>
+              <a:t>)</a:t>
+            </a:r>
+            <a:endParaRPr b="0" i="0" sz="2200" u="sng" cap="none" strike="noStrike">
+              <a:solidFill>
+                <a:srgbClr val="2E75B5"/>
+              </a:solidFill>
+              <a:latin typeface="Arial"/>
+              <a:ea typeface="Arial"/>
+              <a:cs typeface="Arial"/>
+              <a:sym typeface="Arial"/>
+            </a:endParaRPr>
+          </a:p>
+        </p:txBody>
+      </p:sp>
+      <p:sp>
+        <p:nvSpPr>
+          <p:cNvPr id="461" name="Google Shape;461;p49"/>
+          <p:cNvSpPr txBox="1"/>
+          <p:nvPr/>
+        </p:nvSpPr>
+        <p:spPr>
+          <a:xfrm>
+            <a:off x="657226" y="1724787"/>
+            <a:ext cx="10820400" cy="3939500"/>
           </a:xfrm>
           <a:prstGeom prst="rect">
             <a:avLst/>
@@ -14430,38 +14520,157 @@
             <a:r>
               <a:rPr b="0" i="0" lang="pt-BR" sz="2000" u="none" cap="none" strike="noStrike">
                 <a:solidFill>
-                  <a:schemeClr val="dk1"/>
+                  <a:srgbClr val="000000"/>
                 </a:solidFill>
                 <a:latin typeface="Verdana"/>
                 <a:ea typeface="Verdana"/>
                 <a:cs typeface="Verdana"/>
                 <a:sym typeface="Verdana"/>
               </a:rPr>
-              <a:t>ROM, ou Memória Somente de Leitura (</a:t>
+              <a:t>No Windows, de forma geral, as operações de arrastar objetos com o mouse produzem resultados diferentes se as fizermos mantendo as teclas </a:t>
             </a:r>
             <a:r>
-              <a:rPr b="0" i="1" lang="pt-BR" sz="2000" u="none" cap="none" strike="noStrike">
-                <a:solidFill>
-                  <a:schemeClr val="dk1"/>
+              <a:rPr b="1" i="0" lang="pt-BR" sz="2000" u="none" cap="none" strike="noStrike">
+                <a:solidFill>
+                  <a:srgbClr val="000000"/>
                 </a:solidFill>
                 <a:latin typeface="Verdana"/>
                 <a:ea typeface="Verdana"/>
                 <a:cs typeface="Verdana"/>
                 <a:sym typeface="Verdana"/>
               </a:rPr>
-              <a:t>Read-Only Memory</a:t>
+              <a:t>CTRL</a:t>
             </a:r>
             <a:r>
               <a:rPr b="0" i="0" lang="pt-BR" sz="2000" u="none" cap="none" strike="noStrike">
                 <a:solidFill>
-                  <a:schemeClr val="dk1"/>
+                  <a:srgbClr val="000000"/>
                 </a:solidFill>
                 <a:latin typeface="Verdana"/>
                 <a:ea typeface="Verdana"/>
                 <a:cs typeface="Verdana"/>
                 <a:sym typeface="Verdana"/>
               </a:rPr>
-              <a:t>), é um tipo de memória de computador que retém seus dados permanentemente, mesmo quando a energia é desligada. Os dados em uma ROM são gravados durante a fabricação do chip e não podem ser alterados ou regravados depois.</a:t>
+              <a:t>, </a:t>
+            </a:r>
+            <a:r>
+              <a:rPr b="1" i="0" lang="pt-BR" sz="2000" u="none" cap="none" strike="noStrike">
+                <a:solidFill>
+                  <a:srgbClr val="000000"/>
+                </a:solidFill>
+                <a:latin typeface="Verdana"/>
+                <a:ea typeface="Verdana"/>
+                <a:cs typeface="Verdana"/>
+                <a:sym typeface="Verdana"/>
+              </a:rPr>
+              <a:t>SHIFT</a:t>
+            </a:r>
+            <a:r>
+              <a:rPr b="0" i="0" lang="pt-BR" sz="2000" u="none" cap="none" strike="noStrike">
+                <a:solidFill>
+                  <a:srgbClr val="000000"/>
+                </a:solidFill>
+                <a:latin typeface="Verdana"/>
+                <a:ea typeface="Verdana"/>
+                <a:cs typeface="Verdana"/>
+                <a:sym typeface="Verdana"/>
+              </a:rPr>
+              <a:t> ou </a:t>
+            </a:r>
+            <a:r>
+              <a:rPr b="1" i="0" lang="pt-BR" sz="2000" u="none" cap="none" strike="noStrike">
+                <a:solidFill>
+                  <a:srgbClr val="000000"/>
+                </a:solidFill>
+                <a:latin typeface="Verdana"/>
+                <a:ea typeface="Verdana"/>
+                <a:cs typeface="Verdana"/>
+                <a:sym typeface="Verdana"/>
+              </a:rPr>
+              <a:t>ALT</a:t>
+            </a:r>
+            <a:r>
+              <a:rPr b="0" i="0" lang="pt-BR" sz="2000" u="none" cap="none" strike="noStrike">
+                <a:solidFill>
+                  <a:srgbClr val="000000"/>
+                </a:solidFill>
+                <a:latin typeface="Verdana"/>
+                <a:ea typeface="Verdana"/>
+                <a:cs typeface="Verdana"/>
+                <a:sym typeface="Verdana"/>
+              </a:rPr>
+              <a:t> pressionadas.</a:t>
+            </a:r>
+            <a:endParaRPr b="0" i="0" sz="2000" u="none" cap="none" strike="noStrike">
+              <a:solidFill>
+                <a:srgbClr val="000000"/>
+              </a:solidFill>
+              <a:latin typeface="Verdana"/>
+              <a:ea typeface="Verdana"/>
+              <a:cs typeface="Verdana"/>
+              <a:sym typeface="Verdana"/>
+            </a:endParaRPr>
+          </a:p>
+          <a:p>
+            <a:pPr indent="0" lvl="0" marL="0" marR="0" rtl="0" algn="just">
+              <a:lnSpc>
+                <a:spcPct val="110000"/>
+              </a:lnSpc>
+              <a:spcBef>
+                <a:spcPts val="600"/>
+              </a:spcBef>
+              <a:spcAft>
+                <a:spcPts val="0"/>
+              </a:spcAft>
+              <a:buClr>
+                <a:srgbClr val="000000"/>
+              </a:buClr>
+              <a:buSzPts val="2000"/>
+              <a:buFont typeface="Arial"/>
+              <a:buNone/>
+            </a:pPr>
+            <a:r>
+              <a:t/>
+            </a:r>
+            <a:endParaRPr b="0" i="0" sz="2000" u="none" cap="none" strike="noStrike">
+              <a:solidFill>
+                <a:srgbClr val="000000"/>
+              </a:solidFill>
+              <a:latin typeface="Verdana"/>
+              <a:ea typeface="Verdana"/>
+              <a:cs typeface="Verdana"/>
+              <a:sym typeface="Verdana"/>
+            </a:endParaRPr>
+          </a:p>
+          <a:p>
+            <a:pPr indent="0" lvl="0" marL="0" marR="0" rtl="0" algn="just">
+              <a:lnSpc>
+                <a:spcPct val="110000"/>
+              </a:lnSpc>
+              <a:spcBef>
+                <a:spcPts val="600"/>
+              </a:spcBef>
+              <a:spcAft>
+                <a:spcPts val="0"/>
+              </a:spcAft>
+              <a:buClr>
+                <a:srgbClr val="000000"/>
+              </a:buClr>
+              <a:buSzPts val="2000"/>
+              <a:buFont typeface="Arial"/>
+              <a:buNone/>
+            </a:pPr>
+            <a:r>
+              <a:rPr b="0" i="0" lang="pt-BR" sz="2000" u="none" cap="none" strike="noStrike">
+                <a:solidFill>
+                  <a:srgbClr val="000000"/>
+                </a:solidFill>
+                <a:latin typeface="Verdana"/>
+                <a:ea typeface="Verdana"/>
+                <a:cs typeface="Verdana"/>
+                <a:sym typeface="Verdana"/>
+              </a:rPr>
+              <a:t>Arrastando um objeto com a tecla:</a:t>
             </a:r>
             <a:endParaRPr b="0" i="0" sz="1400" u="none" cap="none" strike="noStrike">
               <a:solidFill>
@@ -14473,94 +14682,335 @@
               <a:sym typeface="Arial"/>
             </a:endParaRPr>
           </a:p>
-        </p:txBody>
-      </p:sp>
-      <p:sp>
-        <p:nvSpPr>
-          <p:cNvPr id="135" name="Google Shape;135;p8"/>
-          <p:cNvSpPr txBox="1"/>
-          <p:nvPr/>
-        </p:nvSpPr>
-        <p:spPr>
-          <a:xfrm>
-            <a:off x="463296" y="906105"/>
-            <a:ext cx="11119104" cy="461624"/>
-          </a:xfrm>
-          <a:prstGeom prst="rect">
-            <a:avLst/>
-          </a:prstGeom>
-          <a:noFill/>
-          <a:ln>
-            <a:noFill/>
-          </a:ln>
-        </p:spPr>
-        <p:txBody>
-          <a:bodyPr anchorCtr="0" anchor="t" bIns="45700" lIns="91425" spcFirstLastPara="1" rIns="91425" wrap="square" tIns="45700">
-            <a:spAutoFit/>
-          </a:bodyPr>
-          <a:lstStyle/>
           <a:p>
-            <a:pPr indent="0" lvl="0" marL="0" marR="0" rtl="0" algn="l">
-              <a:lnSpc>
-                <a:spcPct val="100000"/>
-              </a:lnSpc>
-              <a:spcBef>
-                <a:spcPts val="0"/>
-              </a:spcBef>
-              <a:spcAft>
-                <a:spcPts val="0"/>
-              </a:spcAft>
-              <a:buClr>
-                <a:srgbClr val="000000"/>
-              </a:buClr>
-              <a:buSzPts val="2400"/>
+            <a:pPr indent="0" lvl="0" marL="0" marR="0" rtl="0" algn="just">
+              <a:lnSpc>
+                <a:spcPct val="110000"/>
+              </a:lnSpc>
+              <a:spcBef>
+                <a:spcPts val="600"/>
+              </a:spcBef>
+              <a:spcAft>
+                <a:spcPts val="0"/>
+              </a:spcAft>
+              <a:buClr>
+                <a:srgbClr val="000000"/>
+              </a:buClr>
+              <a:buSzPts val="2000"/>
               <a:buFont typeface="Arial"/>
               <a:buNone/>
             </a:pPr>
             <a:r>
-              <a:rPr b="1" i="0" lang="pt-BR" sz="2400" u="none" cap="none" strike="noStrike">
-                <a:solidFill>
-                  <a:srgbClr val="2E75B5"/>
+              <a:t/>
+            </a:r>
+            <a:endParaRPr b="0" i="0" sz="2000" u="none" cap="none" strike="noStrike">
+              <a:solidFill>
+                <a:srgbClr val="000000"/>
+              </a:solidFill>
+              <a:latin typeface="Verdana"/>
+              <a:ea typeface="Verdana"/>
+              <a:cs typeface="Verdana"/>
+              <a:sym typeface="Verdana"/>
+            </a:endParaRPr>
+          </a:p>
+          <a:p>
+            <a:pPr indent="0" lvl="0" marL="0" marR="0" rtl="0" algn="just">
+              <a:lnSpc>
+                <a:spcPct val="110000"/>
+              </a:lnSpc>
+              <a:spcBef>
+                <a:spcPts val="600"/>
+              </a:spcBef>
+              <a:spcAft>
+                <a:spcPts val="0"/>
+              </a:spcAft>
+              <a:buClr>
+                <a:srgbClr val="000000"/>
+              </a:buClr>
+              <a:buSzPts val="2000"/>
+              <a:buFont typeface="Arial"/>
+              <a:buNone/>
+            </a:pPr>
+            <a:r>
+              <a:rPr b="1" i="0" lang="pt-BR" sz="2000" u="sng" cap="none" strike="noStrike">
+                <a:solidFill>
+                  <a:srgbClr val="000000"/>
                 </a:solidFill>
                 <a:latin typeface="Verdana"/>
                 <a:ea typeface="Verdana"/>
                 <a:cs typeface="Verdana"/>
                 <a:sym typeface="Verdana"/>
               </a:rPr>
-              <a:t>ROM (</a:t>
+              <a:t>C</a:t>
             </a:r>
             <a:r>
-              <a:rPr b="1" i="1" lang="pt-BR" sz="2400" u="none" cap="none" strike="noStrike">
-                <a:solidFill>
-                  <a:srgbClr val="2E75B5"/>
+              <a:rPr b="1" i="0" lang="pt-BR" sz="2000" u="none" cap="none" strike="noStrike">
+                <a:solidFill>
+                  <a:srgbClr val="000000"/>
                 </a:solidFill>
                 <a:latin typeface="Verdana"/>
                 <a:ea typeface="Verdana"/>
                 <a:cs typeface="Verdana"/>
                 <a:sym typeface="Verdana"/>
               </a:rPr>
-              <a:t>Read-Only Memory</a:t>
+              <a:t>TRL</a:t>
             </a:r>
             <a:r>
-              <a:rPr b="1" i="0" lang="pt-BR" sz="2400" u="none" cap="none" strike="noStrike">
-                <a:solidFill>
-                  <a:srgbClr val="2E75B5"/>
+              <a:rPr b="0" i="0" lang="pt-BR" sz="2000" u="none" cap="none" strike="noStrike">
+                <a:solidFill>
+                  <a:srgbClr val="000000"/>
                 </a:solidFill>
                 <a:latin typeface="Verdana"/>
                 <a:ea typeface="Verdana"/>
                 <a:cs typeface="Verdana"/>
                 <a:sym typeface="Verdana"/>
               </a:rPr>
-              <a:t>)</a:t>
+              <a:t> pressionada, o Windows cria uma </a:t>
             </a:r>
-            <a:endParaRPr b="0" i="0" sz="2400" u="none" cap="none" strike="noStrike">
+            <a:r>
+              <a:rPr b="1" i="0" lang="pt-BR" sz="2000" u="sng" cap="none" strike="noStrike">
+                <a:solidFill>
+                  <a:srgbClr val="000000"/>
+                </a:solidFill>
+                <a:latin typeface="Verdana"/>
+                <a:ea typeface="Verdana"/>
+                <a:cs typeface="Verdana"/>
+                <a:sym typeface="Verdana"/>
+              </a:rPr>
+              <a:t>C</a:t>
+            </a:r>
+            <a:r>
+              <a:rPr b="1" i="0" lang="pt-BR" sz="2000" u="none" cap="none" strike="noStrike">
+                <a:solidFill>
+                  <a:srgbClr val="000000"/>
+                </a:solidFill>
+                <a:latin typeface="Verdana"/>
+                <a:ea typeface="Verdana"/>
+                <a:cs typeface="Verdana"/>
+                <a:sym typeface="Verdana"/>
+              </a:rPr>
+              <a:t>ÓPIA</a:t>
+            </a:r>
+            <a:r>
+              <a:rPr b="0" i="0" lang="pt-BR" sz="2000" u="none" cap="none" strike="noStrike">
+                <a:solidFill>
+                  <a:srgbClr val="000000"/>
+                </a:solidFill>
+                <a:latin typeface="Verdana"/>
+                <a:ea typeface="Verdana"/>
+                <a:cs typeface="Verdana"/>
+                <a:sym typeface="Verdana"/>
+              </a:rPr>
+              <a:t> do objeto no local onde ele será solto. </a:t>
+            </a:r>
+            <a:endParaRPr b="0" i="0" sz="2000" u="none" cap="none" strike="noStrike">
               <a:solidFill>
-                <a:srgbClr val="2E75B5"/>
+                <a:srgbClr val="000000"/>
               </a:solidFill>
-              <a:latin typeface="Arial"/>
-              <a:ea typeface="Arial"/>
-              <a:cs typeface="Arial"/>
-              <a:sym typeface="Arial"/>
+              <a:latin typeface="Verdana"/>
+              <a:ea typeface="Verdana"/>
+              <a:cs typeface="Verdana"/>
+              <a:sym typeface="Verdana"/>
+            </a:endParaRPr>
+          </a:p>
+          <a:p>
+            <a:pPr indent="0" lvl="0" marL="0" marR="0" rtl="0" algn="just">
+              <a:lnSpc>
+                <a:spcPct val="110000"/>
+              </a:lnSpc>
+              <a:spcBef>
+                <a:spcPts val="600"/>
+              </a:spcBef>
+              <a:spcAft>
+                <a:spcPts val="0"/>
+              </a:spcAft>
+              <a:buClr>
+                <a:srgbClr val="000000"/>
+              </a:buClr>
+              <a:buSzPts val="2000"/>
+              <a:buFont typeface="Arial"/>
+              <a:buNone/>
+            </a:pPr>
+            <a:r>
+              <a:rPr b="1" i="0" lang="pt-BR" sz="2000" u="sng" cap="none" strike="noStrike">
+                <a:solidFill>
+                  <a:srgbClr val="000000"/>
+                </a:solidFill>
+                <a:latin typeface="Verdana"/>
+                <a:ea typeface="Verdana"/>
+                <a:cs typeface="Verdana"/>
+                <a:sym typeface="Verdana"/>
+              </a:rPr>
+              <a:t>S</a:t>
+            </a:r>
+            <a:r>
+              <a:rPr b="1" i="0" lang="pt-BR" sz="2000" u="none" cap="none" strike="noStrike">
+                <a:solidFill>
+                  <a:srgbClr val="000000"/>
+                </a:solidFill>
+                <a:latin typeface="Verdana"/>
+                <a:ea typeface="Verdana"/>
+                <a:cs typeface="Verdana"/>
+                <a:sym typeface="Verdana"/>
+              </a:rPr>
+              <a:t>HIFT</a:t>
+            </a:r>
+            <a:r>
+              <a:rPr b="0" i="0" lang="pt-BR" sz="2000" u="none" cap="none" strike="noStrike">
+                <a:solidFill>
+                  <a:srgbClr val="000000"/>
+                </a:solidFill>
+                <a:latin typeface="Verdana"/>
+                <a:ea typeface="Verdana"/>
+                <a:cs typeface="Verdana"/>
+                <a:sym typeface="Verdana"/>
+              </a:rPr>
+              <a:t> pressionada, o Windows </a:t>
+            </a:r>
+            <a:r>
+              <a:rPr b="1" i="0" lang="pt-BR" sz="2000" u="sng" cap="none" strike="noStrike">
+                <a:solidFill>
+                  <a:srgbClr val="000000"/>
+                </a:solidFill>
+                <a:latin typeface="Verdana"/>
+                <a:ea typeface="Verdana"/>
+                <a:cs typeface="Verdana"/>
+                <a:sym typeface="Verdana"/>
+              </a:rPr>
+              <a:t>S</a:t>
+            </a:r>
+            <a:r>
+              <a:rPr b="1" i="0" lang="pt-BR" sz="2000" u="none" cap="none" strike="noStrike">
+                <a:solidFill>
+                  <a:srgbClr val="000000"/>
+                </a:solidFill>
+                <a:latin typeface="Verdana"/>
+                <a:ea typeface="Verdana"/>
+                <a:cs typeface="Verdana"/>
+                <a:sym typeface="Verdana"/>
+              </a:rPr>
+              <a:t>AI/MOVE </a:t>
+            </a:r>
+            <a:r>
+              <a:rPr b="0" i="0" lang="pt-BR" sz="2000" u="none" cap="none" strike="noStrike">
+                <a:solidFill>
+                  <a:srgbClr val="000000"/>
+                </a:solidFill>
+                <a:latin typeface="Verdana"/>
+                <a:ea typeface="Verdana"/>
+                <a:cs typeface="Verdana"/>
+                <a:sym typeface="Verdana"/>
+              </a:rPr>
+              <a:t>o objeto no local onde ele será solto.</a:t>
+            </a:r>
+            <a:endParaRPr b="0" i="0" sz="2000" u="none" cap="none" strike="noStrike">
+              <a:solidFill>
+                <a:srgbClr val="000000"/>
+              </a:solidFill>
+              <a:latin typeface="Verdana"/>
+              <a:ea typeface="Verdana"/>
+              <a:cs typeface="Verdana"/>
+              <a:sym typeface="Verdana"/>
+            </a:endParaRPr>
+          </a:p>
+          <a:p>
+            <a:pPr indent="0" lvl="0" marL="0" marR="0" rtl="0" algn="just">
+              <a:lnSpc>
+                <a:spcPct val="110000"/>
+              </a:lnSpc>
+              <a:spcBef>
+                <a:spcPts val="600"/>
+              </a:spcBef>
+              <a:spcAft>
+                <a:spcPts val="0"/>
+              </a:spcAft>
+              <a:buClr>
+                <a:srgbClr val="000000"/>
+              </a:buClr>
+              <a:buSzPts val="2000"/>
+              <a:buFont typeface="Arial"/>
+              <a:buNone/>
+            </a:pPr>
+            <a:r>
+              <a:rPr b="1" i="0" lang="pt-BR" sz="2000" u="sng" cap="none" strike="noStrike">
+                <a:solidFill>
+                  <a:srgbClr val="000000"/>
+                </a:solidFill>
+                <a:latin typeface="Verdana"/>
+                <a:ea typeface="Verdana"/>
+                <a:cs typeface="Verdana"/>
+                <a:sym typeface="Verdana"/>
+              </a:rPr>
+              <a:t>A</a:t>
+            </a:r>
+            <a:r>
+              <a:rPr b="1" i="0" lang="pt-BR" sz="2000" u="none" cap="none" strike="noStrike">
+                <a:solidFill>
+                  <a:srgbClr val="000000"/>
+                </a:solidFill>
+                <a:latin typeface="Verdana"/>
+                <a:ea typeface="Verdana"/>
+                <a:cs typeface="Verdana"/>
+                <a:sym typeface="Verdana"/>
+              </a:rPr>
+              <a:t>LT</a:t>
+            </a:r>
+            <a:r>
+              <a:rPr b="0" i="0" lang="pt-BR" sz="2000" u="none" cap="none" strike="noStrike">
+                <a:solidFill>
+                  <a:srgbClr val="000000"/>
+                </a:solidFill>
+                <a:latin typeface="Verdana"/>
+                <a:ea typeface="Verdana"/>
+                <a:cs typeface="Verdana"/>
+                <a:sym typeface="Verdana"/>
+              </a:rPr>
+              <a:t> pressionada, o Windows cria um </a:t>
+            </a:r>
+            <a:r>
+              <a:rPr b="1" i="0" lang="pt-BR" sz="2000" u="sng" cap="none" strike="noStrike">
+                <a:solidFill>
+                  <a:srgbClr val="000000"/>
+                </a:solidFill>
+                <a:latin typeface="Verdana"/>
+                <a:ea typeface="Verdana"/>
+                <a:cs typeface="Verdana"/>
+                <a:sym typeface="Verdana"/>
+              </a:rPr>
+              <a:t>ALT</a:t>
+            </a:r>
+            <a:r>
+              <a:rPr b="1" i="0" lang="pt-BR" sz="2000" u="none" cap="none" strike="noStrike">
+                <a:solidFill>
+                  <a:srgbClr val="000000"/>
+                </a:solidFill>
+                <a:latin typeface="Verdana"/>
+                <a:ea typeface="Verdana"/>
+                <a:cs typeface="Verdana"/>
+                <a:sym typeface="Verdana"/>
+              </a:rPr>
+              <a:t>alho</a:t>
+            </a:r>
+            <a:r>
+              <a:rPr b="0" i="0" lang="pt-BR" sz="2000" u="none" cap="none" strike="noStrike">
+                <a:solidFill>
+                  <a:srgbClr val="000000"/>
+                </a:solidFill>
+                <a:latin typeface="Verdana"/>
+                <a:ea typeface="Verdana"/>
+                <a:cs typeface="Verdana"/>
+                <a:sym typeface="Verdana"/>
+              </a:rPr>
+              <a:t> para o objeto no local onde ele será solto.</a:t>
+            </a:r>
+            <a:endParaRPr b="0" i="0" sz="2000" u="none" cap="none" strike="noStrike">
+              <a:solidFill>
+                <a:srgbClr val="000000"/>
+              </a:solidFill>
+              <a:latin typeface="Verdana"/>
+              <a:ea typeface="Verdana"/>
+              <a:cs typeface="Verdana"/>
+              <a:sym typeface="Verdana"/>
             </a:endParaRPr>
           </a:p>
         </p:txBody>

</xml_diff>